<commit_message>
Populate first dsa5 dataset
</commit_message>
<xml_diff>
--- a/brand/logo.pptx
+++ b/brand/logo.pptx
@@ -6,6 +6,7 @@
   </p:sldMasterIdLst>
   <p:sldIdLst>
     <p:sldId id="256" r:id="rId2"/>
+    <p:sldId id="257" r:id="rId3"/>
   </p:sldIdLst>
   <p:sldSz cx="12192000" cy="6858000"/>
   <p:notesSz cx="6858000" cy="9144000"/>
@@ -4105,6 +4106,451 @@
 </p:sld>
 </file>
 
+<file path=ppt/slides/slide2.xml><?xml version="1.0" encoding="utf-8"?>
+<p:sld xmlns:a="http://schemas.openxmlformats.org/drawingml/2006/main" xmlns:r="http://schemas.openxmlformats.org/officeDocument/2006/relationships" xmlns:p="http://schemas.openxmlformats.org/presentationml/2006/main">
+  <p:cSld>
+    <p:spTree>
+      <p:nvGrpSpPr>
+        <p:cNvPr id="1" name="">
+          <a:extLst>
+            <a:ext uri="{FF2B5EF4-FFF2-40B4-BE49-F238E27FC236}">
+              <a16:creationId xmlns:a16="http://schemas.microsoft.com/office/drawing/2014/main" id="{31376799-E038-03D6-241E-1A876D70F995}"/>
+            </a:ext>
+          </a:extLst>
+        </p:cNvPr>
+        <p:cNvGrpSpPr/>
+        <p:nvPr/>
+      </p:nvGrpSpPr>
+      <p:grpSpPr>
+        <a:xfrm>
+          <a:off x="0" y="0"/>
+          <a:ext cx="0" cy="0"/>
+          <a:chOff x="0" y="0"/>
+          <a:chExt cx="0" cy="0"/>
+        </a:xfrm>
+      </p:grpSpPr>
+      <p:grpSp>
+        <p:nvGrpSpPr>
+          <p:cNvPr id="3" name="Group 2">
+            <a:extLst>
+              <a:ext uri="{FF2B5EF4-FFF2-40B4-BE49-F238E27FC236}">
+                <a16:creationId xmlns:a16="http://schemas.microsoft.com/office/drawing/2014/main" id="{044CBAC1-AF51-363B-5D28-0B3EB9914C04}"/>
+              </a:ext>
+            </a:extLst>
+          </p:cNvPr>
+          <p:cNvGrpSpPr/>
+          <p:nvPr/>
+        </p:nvGrpSpPr>
+        <p:grpSpPr>
+          <a:xfrm>
+            <a:off x="1394790" y="2083331"/>
+            <a:ext cx="3611222" cy="3620978"/>
+            <a:chOff x="1394790" y="2083331"/>
+            <a:chExt cx="3611222" cy="3620978"/>
+          </a:xfrm>
+        </p:grpSpPr>
+        <p:sp>
+          <p:nvSpPr>
+            <p:cNvPr id="2" name="Rounded Rectangle 1">
+              <a:extLst>
+                <a:ext uri="{FF2B5EF4-FFF2-40B4-BE49-F238E27FC236}">
+                  <a16:creationId xmlns:a16="http://schemas.microsoft.com/office/drawing/2014/main" id="{75576D8D-9E2D-0457-1F1F-BA542ED61AB7}"/>
+                </a:ext>
+              </a:extLst>
+            </p:cNvPr>
+            <p:cNvSpPr/>
+            <p:nvPr/>
+          </p:nvSpPr>
+          <p:spPr>
+            <a:xfrm rot="2700000">
+              <a:off x="1389912" y="2088209"/>
+              <a:ext cx="3620978" cy="3611222"/>
+            </a:xfrm>
+            <a:prstGeom prst="roundRect">
+              <a:avLst/>
+            </a:prstGeom>
+            <a:solidFill>
+              <a:schemeClr val="tx1"/>
+            </a:solidFill>
+            <a:ln w="228600">
+              <a:solidFill>
+                <a:schemeClr val="tx1"/>
+              </a:solidFill>
+            </a:ln>
+          </p:spPr>
+          <p:style>
+            <a:lnRef idx="2">
+              <a:schemeClr val="accent1">
+                <a:shade val="15000"/>
+              </a:schemeClr>
+            </a:lnRef>
+            <a:fillRef idx="1">
+              <a:schemeClr val="accent1"/>
+            </a:fillRef>
+            <a:effectRef idx="0">
+              <a:schemeClr val="accent1"/>
+            </a:effectRef>
+            <a:fontRef idx="minor">
+              <a:schemeClr val="lt1"/>
+            </a:fontRef>
+          </p:style>
+          <p:txBody>
+            <a:bodyPr rtlCol="0" anchor="ctr"/>
+            <a:lstStyle/>
+            <a:p>
+              <a:pPr algn="ctr"/>
+              <a:endParaRPr lang="en-US"/>
+            </a:p>
+          </p:txBody>
+        </p:sp>
+        <p:grpSp>
+          <p:nvGrpSpPr>
+            <p:cNvPr id="11" name="Group 10">
+              <a:extLst>
+                <a:ext uri="{FF2B5EF4-FFF2-40B4-BE49-F238E27FC236}">
+                  <a16:creationId xmlns:a16="http://schemas.microsoft.com/office/drawing/2014/main" id="{61FD84E5-B83D-950A-7536-578B3C508FE8}"/>
+                </a:ext>
+              </a:extLst>
+            </p:cNvPr>
+            <p:cNvGrpSpPr/>
+            <p:nvPr/>
+          </p:nvGrpSpPr>
+          <p:grpSpPr>
+            <a:xfrm>
+              <a:off x="1772341" y="2461902"/>
+              <a:ext cx="2856120" cy="2863836"/>
+              <a:chOff x="4741600" y="2309502"/>
+              <a:chExt cx="2856120" cy="2863836"/>
+            </a:xfrm>
+            <a:noFill/>
+          </p:grpSpPr>
+          <p:sp>
+            <p:nvSpPr>
+              <p:cNvPr id="4" name="Rounded Rectangle 3">
+                <a:extLst>
+                  <a:ext uri="{FF2B5EF4-FFF2-40B4-BE49-F238E27FC236}">
+                    <a16:creationId xmlns:a16="http://schemas.microsoft.com/office/drawing/2014/main" id="{0A6D0A2D-3AA6-F925-6CF6-7A29FF7549E7}"/>
+                  </a:ext>
+                </a:extLst>
+              </p:cNvPr>
+              <p:cNvSpPr/>
+              <p:nvPr/>
+            </p:nvSpPr>
+            <p:spPr>
+              <a:xfrm rot="2700000">
+                <a:off x="4737742" y="2313360"/>
+                <a:ext cx="2863836" cy="2856120"/>
+              </a:xfrm>
+              <a:prstGeom prst="roundRect">
+                <a:avLst/>
+              </a:prstGeom>
+              <a:grpFill/>
+              <a:ln w="228600">
+                <a:solidFill>
+                  <a:srgbClr val="F7F1E1"/>
+                </a:solidFill>
+              </a:ln>
+            </p:spPr>
+            <p:style>
+              <a:lnRef idx="2">
+                <a:schemeClr val="accent1">
+                  <a:shade val="15000"/>
+                </a:schemeClr>
+              </a:lnRef>
+              <a:fillRef idx="1">
+                <a:schemeClr val="accent1"/>
+              </a:fillRef>
+              <a:effectRef idx="0">
+                <a:schemeClr val="accent1"/>
+              </a:effectRef>
+              <a:fontRef idx="minor">
+                <a:schemeClr val="lt1"/>
+              </a:fontRef>
+            </p:style>
+            <p:txBody>
+              <a:bodyPr rtlCol="0" anchor="ctr"/>
+              <a:lstStyle/>
+              <a:p>
+                <a:pPr algn="ctr"/>
+                <a:endParaRPr lang="en-US"/>
+              </a:p>
+            </p:txBody>
+          </p:sp>
+          <p:sp>
+            <p:nvSpPr>
+              <p:cNvPr id="5" name="Oval 4">
+                <a:extLst>
+                  <a:ext uri="{FF2B5EF4-FFF2-40B4-BE49-F238E27FC236}">
+                    <a16:creationId xmlns:a16="http://schemas.microsoft.com/office/drawing/2014/main" id="{1C3B923C-B5DE-43A6-6831-4F78B38EFA04}"/>
+                  </a:ext>
+                </a:extLst>
+              </p:cNvPr>
+              <p:cNvSpPr/>
+              <p:nvPr/>
+            </p:nvSpPr>
+            <p:spPr>
+              <a:xfrm>
+                <a:off x="5939811" y="3511571"/>
+                <a:ext cx="459698" cy="459698"/>
+              </a:xfrm>
+              <a:prstGeom prst="ellipse">
+                <a:avLst/>
+              </a:prstGeom>
+              <a:solidFill>
+                <a:srgbClr val="F7F1E1"/>
+              </a:solidFill>
+              <a:ln>
+                <a:noFill/>
+              </a:ln>
+            </p:spPr>
+            <p:style>
+              <a:lnRef idx="2">
+                <a:schemeClr val="accent1">
+                  <a:shade val="15000"/>
+                </a:schemeClr>
+              </a:lnRef>
+              <a:fillRef idx="1">
+                <a:schemeClr val="accent1"/>
+              </a:fillRef>
+              <a:effectRef idx="0">
+                <a:schemeClr val="accent1"/>
+              </a:effectRef>
+              <a:fontRef idx="minor">
+                <a:schemeClr val="lt1"/>
+              </a:fontRef>
+            </p:style>
+            <p:txBody>
+              <a:bodyPr rtlCol="0" anchor="ctr"/>
+              <a:lstStyle/>
+              <a:p>
+                <a:pPr algn="ctr"/>
+                <a:endParaRPr lang="en-US" dirty="0"/>
+              </a:p>
+            </p:txBody>
+          </p:sp>
+          <p:sp>
+            <p:nvSpPr>
+              <p:cNvPr id="6" name="Oval 5">
+                <a:extLst>
+                  <a:ext uri="{FF2B5EF4-FFF2-40B4-BE49-F238E27FC236}">
+                    <a16:creationId xmlns:a16="http://schemas.microsoft.com/office/drawing/2014/main" id="{823570E6-20B2-72C7-28B8-5A6BC5BB7186}"/>
+                  </a:ext>
+                </a:extLst>
+              </p:cNvPr>
+              <p:cNvSpPr/>
+              <p:nvPr/>
+            </p:nvSpPr>
+            <p:spPr>
+              <a:xfrm>
+                <a:off x="5939811" y="2592175"/>
+                <a:ext cx="459698" cy="459698"/>
+              </a:xfrm>
+              <a:prstGeom prst="ellipse">
+                <a:avLst/>
+              </a:prstGeom>
+              <a:solidFill>
+                <a:srgbClr val="F7F1E1"/>
+              </a:solidFill>
+              <a:ln>
+                <a:noFill/>
+              </a:ln>
+            </p:spPr>
+            <p:style>
+              <a:lnRef idx="2">
+                <a:schemeClr val="accent1">
+                  <a:shade val="15000"/>
+                </a:schemeClr>
+              </a:lnRef>
+              <a:fillRef idx="1">
+                <a:schemeClr val="accent1"/>
+              </a:fillRef>
+              <a:effectRef idx="0">
+                <a:schemeClr val="accent1"/>
+              </a:effectRef>
+              <a:fontRef idx="minor">
+                <a:schemeClr val="lt1"/>
+              </a:fontRef>
+            </p:style>
+            <p:txBody>
+              <a:bodyPr rtlCol="0" anchor="ctr"/>
+              <a:lstStyle/>
+              <a:p>
+                <a:pPr algn="ctr"/>
+                <a:endParaRPr lang="en-US" dirty="0"/>
+              </a:p>
+            </p:txBody>
+          </p:sp>
+          <p:sp>
+            <p:nvSpPr>
+              <p:cNvPr id="7" name="Oval 6">
+                <a:extLst>
+                  <a:ext uri="{FF2B5EF4-FFF2-40B4-BE49-F238E27FC236}">
+                    <a16:creationId xmlns:a16="http://schemas.microsoft.com/office/drawing/2014/main" id="{0EF7DB0C-F51E-8875-8D1C-18F13E010060}"/>
+                  </a:ext>
+                </a:extLst>
+              </p:cNvPr>
+              <p:cNvSpPr/>
+              <p:nvPr/>
+            </p:nvSpPr>
+            <p:spPr>
+              <a:xfrm>
+                <a:off x="5939811" y="4430967"/>
+                <a:ext cx="459698" cy="459698"/>
+              </a:xfrm>
+              <a:prstGeom prst="ellipse">
+                <a:avLst/>
+              </a:prstGeom>
+              <a:solidFill>
+                <a:srgbClr val="F7F1E1"/>
+              </a:solidFill>
+              <a:ln>
+                <a:noFill/>
+              </a:ln>
+            </p:spPr>
+            <p:style>
+              <a:lnRef idx="2">
+                <a:schemeClr val="accent1">
+                  <a:shade val="15000"/>
+                </a:schemeClr>
+              </a:lnRef>
+              <a:fillRef idx="1">
+                <a:schemeClr val="accent1"/>
+              </a:fillRef>
+              <a:effectRef idx="0">
+                <a:schemeClr val="accent1"/>
+              </a:effectRef>
+              <a:fontRef idx="minor">
+                <a:schemeClr val="lt1"/>
+              </a:fontRef>
+            </p:style>
+            <p:txBody>
+              <a:bodyPr rtlCol="0" anchor="ctr"/>
+              <a:lstStyle/>
+              <a:p>
+                <a:pPr algn="ctr"/>
+                <a:endParaRPr lang="en-US"/>
+              </a:p>
+            </p:txBody>
+          </p:sp>
+          <p:sp>
+            <p:nvSpPr>
+              <p:cNvPr id="8" name="Oval 7">
+                <a:extLst>
+                  <a:ext uri="{FF2B5EF4-FFF2-40B4-BE49-F238E27FC236}">
+                    <a16:creationId xmlns:a16="http://schemas.microsoft.com/office/drawing/2014/main" id="{4B1F1B3D-01B7-F5EE-E3CE-1D94614539BE}"/>
+                  </a:ext>
+                </a:extLst>
+              </p:cNvPr>
+              <p:cNvSpPr/>
+              <p:nvPr/>
+            </p:nvSpPr>
+            <p:spPr>
+              <a:xfrm>
+                <a:off x="5020415" y="3511571"/>
+                <a:ext cx="459698" cy="459698"/>
+              </a:xfrm>
+              <a:prstGeom prst="ellipse">
+                <a:avLst/>
+              </a:prstGeom>
+              <a:solidFill>
+                <a:srgbClr val="F7F1E1"/>
+              </a:solidFill>
+              <a:ln>
+                <a:noFill/>
+              </a:ln>
+            </p:spPr>
+            <p:style>
+              <a:lnRef idx="2">
+                <a:schemeClr val="accent1">
+                  <a:shade val="15000"/>
+                </a:schemeClr>
+              </a:lnRef>
+              <a:fillRef idx="1">
+                <a:schemeClr val="accent1"/>
+              </a:fillRef>
+              <a:effectRef idx="0">
+                <a:schemeClr val="accent1"/>
+              </a:effectRef>
+              <a:fontRef idx="minor">
+                <a:schemeClr val="lt1"/>
+              </a:fontRef>
+            </p:style>
+            <p:txBody>
+              <a:bodyPr rtlCol="0" anchor="ctr"/>
+              <a:lstStyle/>
+              <a:p>
+                <a:pPr algn="ctr"/>
+                <a:endParaRPr lang="en-US"/>
+              </a:p>
+            </p:txBody>
+          </p:sp>
+          <p:sp>
+            <p:nvSpPr>
+              <p:cNvPr id="10" name="Oval 9">
+                <a:extLst>
+                  <a:ext uri="{FF2B5EF4-FFF2-40B4-BE49-F238E27FC236}">
+                    <a16:creationId xmlns:a16="http://schemas.microsoft.com/office/drawing/2014/main" id="{BC88553E-8AD3-9249-2D78-B56E6C676412}"/>
+                  </a:ext>
+                </a:extLst>
+              </p:cNvPr>
+              <p:cNvSpPr/>
+              <p:nvPr/>
+            </p:nvSpPr>
+            <p:spPr>
+              <a:xfrm>
+                <a:off x="6859207" y="3511571"/>
+                <a:ext cx="459698" cy="459698"/>
+              </a:xfrm>
+              <a:prstGeom prst="ellipse">
+                <a:avLst/>
+              </a:prstGeom>
+              <a:solidFill>
+                <a:srgbClr val="F7F1E1"/>
+              </a:solidFill>
+              <a:ln>
+                <a:noFill/>
+              </a:ln>
+            </p:spPr>
+            <p:style>
+              <a:lnRef idx="2">
+                <a:schemeClr val="accent1">
+                  <a:shade val="15000"/>
+                </a:schemeClr>
+              </a:lnRef>
+              <a:fillRef idx="1">
+                <a:schemeClr val="accent1"/>
+              </a:fillRef>
+              <a:effectRef idx="0">
+                <a:schemeClr val="accent1"/>
+              </a:effectRef>
+              <a:fontRef idx="minor">
+                <a:schemeClr val="lt1"/>
+              </a:fontRef>
+            </p:style>
+            <p:txBody>
+              <a:bodyPr rtlCol="0" anchor="ctr"/>
+              <a:lstStyle/>
+              <a:p>
+                <a:pPr algn="ctr"/>
+                <a:endParaRPr lang="en-US" dirty="0"/>
+              </a:p>
+            </p:txBody>
+          </p:sp>
+        </p:grpSp>
+      </p:grpSp>
+    </p:spTree>
+    <p:extLst>
+      <p:ext uri="{BB962C8B-B14F-4D97-AF65-F5344CB8AC3E}">
+        <p14:creationId xmlns:p14="http://schemas.microsoft.com/office/powerpoint/2010/main" val="2246445765"/>
+      </p:ext>
+    </p:extLst>
+  </p:cSld>
+  <p:clrMapOvr>
+    <a:masterClrMapping/>
+  </p:clrMapOvr>
+</p:sld>
+</file>
+
 <file path=ppt/theme/theme1.xml><?xml version="1.0" encoding="utf-8"?>
 <a:theme xmlns:a="http://schemas.openxmlformats.org/drawingml/2006/main" name="Office Theme">
   <a:themeElements>

</xml_diff>